<commit_message>
Reword model slides: decision based on LS STA location, BSS grouping
Co-Authored-By: Claude Fable 5.1 <noreply@anthropic.com>
Claude-Session: https://claude.ai/code/session_01RNbx7fEwFmbYc2ewK8owVe
</commit_message>
<xml_diff>
--- a/paper/slides/TAG-ST_model_detail_slides.pptx
+++ b/paper/slides/TAG-ST_model_detail_slides.pptx
@@ -1554,7 +1554,7 @@
                 <a:ea typeface="Pretendard" pitchFamily="34" charset="-122"/>
                 <a:cs typeface="Pretendard" pitchFamily="34" charset="-120"/>
               </a:rPr>
-              <a:t>STA: 트래픽 종류(저지연 / 일반)를 가짐. 저지연 STA를 서비스하는 AP = "저지연 서비스 AP"</a:t>
+              <a:t>STA: 트래픽 종류(저지연 / 일반)를 가진 수신 단말. 저지연 STA의 위치가 전송 방식 결정의 근거</a:t>
             </a:r>
             <a:endParaRPr lang="en-US" sz="1250" dirty="0"/>
           </a:p>
@@ -1596,7 +1596,7 @@
                 <a:ea typeface="Pretendard" pitchFamily="34" charset="-122"/>
                 <a:cs typeface="Pretendard" pitchFamily="34" charset="-120"/>
               </a:rPr>
-              <a:t>① 초기화: Master AP가 AP 간 RSSI로 BSS를 그룹화 (배치 동안 고정)</a:t>
+              <a:t>① 초기화: Master AP가 AP 간 RSSI로 가까운 BSS(AP + 소속 STA)끼리 그룹화 (배치 동안 고정)</a:t>
             </a:r>
             <a:endParaRPr lang="en-US" sz="1250" dirty="0"/>
           </a:p>
@@ -1617,7 +1617,7 @@
                 <a:ea typeface="Pretendard" pitchFamily="34" charset="-122"/>
                 <a:cs typeface="Pretendard" pitchFamily="34" charset="-120"/>
               </a:rPr>
-              <a:t>② TXOP마다: 저지연 트래픽 분포 관측 → 협력 방식 결정 → ML로 슬롯·전력 결정 → 협력 전송</a:t>
+              <a:t>② TXOP마다: 저지연 STA가 어느 그룹에 있는지 관측 → 협력 방식 결정 → ML로 슬롯·전력 결정 → 협력 전송</a:t>
             </a:r>
             <a:endParaRPr lang="en-US" sz="1250" dirty="0"/>
           </a:p>
@@ -2083,7 +2083,7 @@
                 <a:ea typeface="Pretendard" pitchFamily="34" charset="-122"/>
                 <a:cs typeface="Pretendard" pitchFamily="34" charset="-120"/>
               </a:rPr>
-              <a:t>그룹 = 서로 가까운 BSS 묶음 → 그룹 간 간섭이 작아 동시 전송(Co-SR)에 유리</a:t>
+              <a:t>그룹 = 서로 가까운 BSS(AP + 소속 STA) 묶음 → 그룹 간 간섭이 작아 동시 전송(Co-SR)에 유리</a:t>
             </a:r>
             <a:endParaRPr lang="en-US" sz="1250" dirty="0"/>
           </a:p>
@@ -2422,7 +2422,7 @@
                 <a:ea typeface="Pretendard" pitchFamily="34" charset="-122"/>
                 <a:cs typeface="Pretendard" pitchFamily="34" charset="-120"/>
               </a:rPr>
-              <a:t>②  TXOP마다: 저지연 트래픽 분포 관측 → 협력 방식 결정</a:t>
+              <a:t>②  TXOP마다: 저지연 STA 위치 관측 → 협력 방식 결정</a:t>
             </a:r>
             <a:endParaRPr lang="en-US" sz="1300" dirty="0"/>
           </a:p>
@@ -2465,7 +2465,7 @@
                 <a:ea typeface="Pretendard" pitchFamily="34" charset="-122"/>
                 <a:cs typeface="Pretendard" pitchFamily="34" charset="-120"/>
               </a:rPr>
-              <a:t>관측: Master AP가 TXOP 획득(EDCA) 후 ICF 전송, 각 AP는 ICR로 "저지연 큐 보유 여부·큐 상태" 응답</a:t>
+              <a:t>관측: Master AP가 TXOP 획득(EDCA) 후 ICF 전송, 각 AP는 ICR로 "보낼 데이터가 있는 저지연 STA 유무·큐 상태" 응답</a:t>
             </a:r>
             <a:endParaRPr lang="en-US" sz="1250" dirty="0"/>
           </a:p>
@@ -2528,7 +2528,7 @@
                 <a:ea typeface="Pretendard" pitchFamily="34" charset="-122"/>
                 <a:cs typeface="Pretendard" pitchFamily="34" charset="-120"/>
               </a:rPr>
-              <a:t>저지연 서비스 AP가 여러 그룹에 분산 (Distributed) → Priority slot: 저지연 서비스 AP만 전송 (다른 그룹끼리 동시, 같은 그룹은 순번), 나머지 AP는 대기 → Shared slot: 전원 Co-SR</a:t>
+              <a:t>저지연 STA가 여러 그룹에 흩어져 있음 (Distributed) → Priority slot: 저지연 STA 앞으로 가는 데이터만 먼저 전송 (다른 그룹끼리 동시, 같은 그룹은 순번), 나머지 AP는 대기 → Shared slot: 전원 Co-SR</a:t>
             </a:r>
             <a:endParaRPr lang="en-US" sz="1250" dirty="0"/>
           </a:p>
@@ -2549,7 +2549,7 @@
                 <a:ea typeface="Pretendard" pitchFamily="34" charset="-122"/>
                 <a:cs typeface="Pretendard" pitchFamily="34" charset="-120"/>
               </a:rPr>
-              <a:t>저지연 서비스 AP가 한 그룹에 집중 (Concentrated) → 그 그룹은 TXOP 전체를 AP별 순차 전송 (Co-TDMA), 다른 그룹은 Co-SR</a:t>
+              <a:t>저지연 STA가 한 그룹에 몰려 있음 (Concentrated) → 그 그룹은 저지연 STA 앞으로 가는 데이터부터 AP별 순차 전송 (Co-TDMA), 다른 그룹은 Co-SR</a:t>
             </a:r>
             <a:endParaRPr lang="en-US" sz="1250" dirty="0"/>
           </a:p>
@@ -2994,7 +2994,7 @@
                 <a:ea typeface="Pretendard" pitchFamily="34" charset="-122"/>
                 <a:cs typeface="Pretendard" pitchFamily="34" charset="-120"/>
               </a:rPr>
-              <a:t>입력: 그룹 구성, 저지연 서비스 AP, 큐 상태 / 보상: 저지연 패킷 전달률 + 전체 전달률</a:t>
+              <a:t>입력: 그룹 구성, 저지연 STA 위치, 큐 상태 / 보상: 저지연 패킷 전달률 + 전체 전달률</a:t>
             </a:r>
             <a:endParaRPr lang="en-US" sz="1250" dirty="0"/>
           </a:p>
@@ -3668,7 +3668,7 @@
                           <a:ea typeface="Pretendard" pitchFamily="34" charset="-122"/>
                           <a:cs typeface="Pretendard" pitchFamily="34" charset="-120"/>
                         </a:rPr>
-                        <a:t>저지연 큐 보유 여부, 큐 상태</a:t>
+                        <a:t>보낼 데이터가 있는 저지연 STA 유무, 큐 상태</a:t>
                       </a:r>
                       <a:endParaRPr lang="en-US" sz="1100" dirty="0">
                         <a:latin typeface="Pretendard" charset="0"/>

</xml_diff>

<commit_message>
Fix deployment figures on model slides: 20 APs in 80 m x 80 m
Co-Authored-By: Claude Fable 5.1 <noreply@anthropic.com>
Claude-Session: https://claude.ai/code/session_01RNbx7fEwFmbYc2ewK8owVe
</commit_message>
<xml_diff>
--- a/paper/slides/TAG-ST_model_detail_slides.pptx
+++ b/paper/slides/TAG-ST_model_detail_slides.pptx
@@ -2125,7 +2125,7 @@
                 <a:ea typeface="Pretendard" pitchFamily="34" charset="-122"/>
                 <a:cs typeface="Pretendard" pitchFamily="34" charset="-120"/>
               </a:rPr>
-              <a:t>12 AP 배치 100회 기준 평균 5.2개 그룹 (최소 3, 최대 8)</a:t>
+              <a:t>80 m × 80 m에 AP 20대 랜덤 배치, 100회 기준 평균 5.2개 그룹 (최소 3, 최대 8)</a:t>
             </a:r>
             <a:endParaRPr lang="en-US" sz="1250" dirty="0"/>
           </a:p>
@@ -4862,7 +4862,7 @@
                 <a:ea typeface="Pretendard" pitchFamily="34" charset="-122"/>
                 <a:cs typeface="Pretendard" pitchFamily="34" charset="-120"/>
               </a:rPr>
-              <a:t>실험 결과 요약 (12 AP, 100회 평균, 총 부하 1000 Mbps)</a:t>
+              <a:t>실험 결과 요약 (80 m × 80 m, AP 20대 · STA 40대, 100회 평균, 총 부하 1000 Mbps)</a:t>
             </a:r>
             <a:endParaRPr lang="en-US" sz="1300" dirty="0"/>
           </a:p>

</xml_diff>